<commit_message>
Rename du challenge release and update branded pitch and architecture
</commit_message>
<xml_diff>
--- a/pitch/Aqion-Relay-Du-Ignyte-Pitch.pptx
+++ b/pitch/Aqion-Relay-Du-Ignyte-Pitch.pptx
@@ -2125,8 +2125,8 @@
         </p:nvSpPr>
         <p:spPr>
           <a:xfrm>
-            <a:off x="10287000" y="396240"/>
-            <a:ext cx="1295400" cy="289560"/>
+            <a:off x="9753600" y="396240"/>
+            <a:ext cx="1828800" cy="289560"/>
           </a:xfrm>
           <a:prstGeom prst="rect">
             <a:avLst/>
@@ -2155,7 +2155,7 @@
                 <a:ea typeface="Instrument Sans" pitchFamily="34" charset="-122"/>
                 <a:cs typeface="Instrument Sans" pitchFamily="34" charset="-120"/>
               </a:rPr>
-              <a:t>AqionLabs</a:t>
+              <a:t>aqionlabs.ai</a:t>
             </a:r>
             <a:endParaRPr lang="en-US" sz="1560" dirty="0"/>
           </a:p>
@@ -2476,29 +2476,29 @@
         </p:nvSpPr>
         <p:spPr>
           <a:xfrm>
-            <a:off x="640080" y="4892040"/>
-            <a:ext cx="1219200" cy="228600"/>
-          </a:xfrm>
-          <a:prstGeom prst="rect">
-            <a:avLst/>
-          </a:prstGeom>
-          <a:noFill/>
-          <a:ln/>
-        </p:spPr>
-        <p:txBody>
-          <a:bodyPr wrap="square" lIns="0" tIns="0" rIns="0" bIns="0" rtlCol="0" anchor="t">
-            <a:spAutoFit/>
-          </a:bodyPr>
-          <a:lstStyle/>
-          <a:p>
-            <a:pPr algn="l" indent="0" marL="0">
-              <a:lnSpc>
-                <a:spcPct val="100000"/>
-              </a:lnSpc>
-              <a:buNone/>
-            </a:pPr>
-            <a:r>
-              <a:rPr lang="en-US" sz="1080" b="1" dirty="0">
+            <a:off x="640080" y="4960620"/>
+            <a:ext cx="1562100" cy="320040"/>
+          </a:xfrm>
+          <a:prstGeom prst="rect">
+            <a:avLst/>
+          </a:prstGeom>
+          <a:noFill/>
+          <a:ln/>
+        </p:spPr>
+        <p:txBody>
+          <a:bodyPr wrap="square" lIns="0" tIns="0" rIns="0" bIns="0" rtlCol="0" anchor="t">
+            <a:spAutoFit/>
+          </a:bodyPr>
+          <a:lstStyle/>
+          <a:p>
+            <a:pPr algn="l" indent="0" marL="0">
+              <a:lnSpc>
+                <a:spcPct val="100000"/>
+              </a:lnSpc>
+              <a:buNone/>
+            </a:pPr>
+            <a:r>
+              <a:rPr lang="en-US" sz="1440" b="1" dirty="0">
                 <a:solidFill>
                   <a:srgbClr val="D3EDE0"/>
                 </a:solidFill>
@@ -2508,7 +2508,7 @@
               </a:rPr>
               <a:t>LIVE MVP</a:t>
             </a:r>
-            <a:endParaRPr lang="en-US" sz="1080" dirty="0"/>
+            <a:endParaRPr lang="en-US" sz="1440" dirty="0"/>
           </a:p>
         </p:txBody>
       </p:sp>
@@ -2522,29 +2522,29 @@
         </p:nvSpPr>
         <p:spPr>
           <a:xfrm>
-            <a:off x="640080" y="5189220"/>
-            <a:ext cx="10591800" cy="320040"/>
-          </a:xfrm>
-          <a:prstGeom prst="rect">
-            <a:avLst/>
-          </a:prstGeom>
-          <a:noFill/>
-          <a:ln/>
-        </p:spPr>
-        <p:txBody>
-          <a:bodyPr wrap="square" lIns="0" tIns="0" rIns="0" bIns="0" rtlCol="0" anchor="t">
-            <a:spAutoFit/>
-          </a:bodyPr>
-          <a:lstStyle/>
-          <a:p>
-            <a:pPr algn="l" indent="0" marL="0">
-              <a:lnSpc>
-                <a:spcPct val="100000"/>
-              </a:lnSpc>
-              <a:buNone/>
-            </a:pPr>
-            <a:r>
-              <a:rPr lang="en-US" sz="1620" u="sng" dirty="0">
+            <a:off x="2362200" y="4960620"/>
+            <a:ext cx="9220200" cy="320040"/>
+          </a:xfrm>
+          <a:prstGeom prst="rect">
+            <a:avLst/>
+          </a:prstGeom>
+          <a:noFill/>
+          <a:ln/>
+        </p:spPr>
+        <p:txBody>
+          <a:bodyPr wrap="square" lIns="0" tIns="0" rIns="0" bIns="0" rtlCol="0" anchor="t">
+            <a:spAutoFit/>
+          </a:bodyPr>
+          <a:lstStyle/>
+          <a:p>
+            <a:pPr algn="l" indent="0" marL="0">
+              <a:lnSpc>
+                <a:spcPct val="100000"/>
+              </a:lnSpc>
+              <a:buNone/>
+            </a:pPr>
+            <a:r>
+              <a:rPr lang="en-US" sz="1440" u="sng" dirty="0">
                 <a:solidFill>
                   <a:srgbClr val="FFFFFF"/>
                 </a:solidFill>
@@ -2559,9 +2559,9 @@
                   </a:extLst>
                 </a:hlinkClick>
               </a:rPr>
-              <a:t>https://aqionrelaydumvp.jafermn.workers.dev</a:t>
-            </a:r>
-            <a:endParaRPr lang="en-US" sz="1620" dirty="0"/>
+              <a:t>https://duignytemvp.aqionlabs.workers.dev</a:t>
+            </a:r>
+            <a:endParaRPr lang="en-US" sz="1440" dirty="0"/>
           </a:p>
         </p:txBody>
       </p:sp>
@@ -2573,29 +2573,29 @@
         </p:nvSpPr>
         <p:spPr>
           <a:xfrm>
-            <a:off x="640080" y="5631180"/>
-            <a:ext cx="1447800" cy="228600"/>
-          </a:xfrm>
-          <a:prstGeom prst="rect">
-            <a:avLst/>
-          </a:prstGeom>
-          <a:noFill/>
-          <a:ln/>
-        </p:spPr>
-        <p:txBody>
-          <a:bodyPr wrap="square" lIns="0" tIns="0" rIns="0" bIns="0" rtlCol="0" anchor="t">
-            <a:spAutoFit/>
-          </a:bodyPr>
-          <a:lstStyle/>
-          <a:p>
-            <a:pPr algn="l" indent="0" marL="0">
-              <a:lnSpc>
-                <a:spcPct val="100000"/>
-              </a:lnSpc>
-              <a:buNone/>
-            </a:pPr>
-            <a:r>
-              <a:rPr lang="en-US" sz="1080" b="1" dirty="0">
+            <a:off x="640080" y="5478780"/>
+            <a:ext cx="1562100" cy="320040"/>
+          </a:xfrm>
+          <a:prstGeom prst="rect">
+            <a:avLst/>
+          </a:prstGeom>
+          <a:noFill/>
+          <a:ln/>
+        </p:spPr>
+        <p:txBody>
+          <a:bodyPr wrap="square" lIns="0" tIns="0" rIns="0" bIns="0" rtlCol="0" anchor="t">
+            <a:spAutoFit/>
+          </a:bodyPr>
+          <a:lstStyle/>
+          <a:p>
+            <a:pPr algn="l" indent="0" marL="0">
+              <a:lnSpc>
+                <a:spcPct val="100000"/>
+              </a:lnSpc>
+              <a:buNone/>
+            </a:pPr>
+            <a:r>
+              <a:rPr lang="en-US" sz="1440" b="1" dirty="0">
                 <a:solidFill>
                   <a:srgbClr val="D3EDE0"/>
                 </a:solidFill>
@@ -2605,7 +2605,7 @@
               </a:rPr>
               <a:t>GITHUB SOURCE</a:t>
             </a:r>
-            <a:endParaRPr lang="en-US" sz="1080" dirty="0"/>
+            <a:endParaRPr lang="en-US" sz="1440" dirty="0"/>
           </a:p>
         </p:txBody>
       </p:sp>
@@ -2619,7 +2619,7 @@
         </p:nvSpPr>
         <p:spPr>
           <a:xfrm>
-            <a:off x="2286000" y="5593080"/>
+            <a:off x="2362200" y="5478780"/>
             <a:ext cx="9220200" cy="320040"/>
           </a:xfrm>
           <a:prstGeom prst="rect">
@@ -2656,7 +2656,7 @@
                   </a:extLst>
                 </a:hlinkClick>
               </a:rPr>
-              <a:t>https://github.com/Jaferdecodesai/Relay_IgnyteDuChallenge</a:t>
+              <a:t>https://github.com/Jaferdecodesai/DuIgnyteMVP_Aqionlabs</a:t>
             </a:r>
             <a:endParaRPr lang="en-US" sz="1440" dirty="0"/>
           </a:p>
@@ -2906,8 +2906,8 @@
         </p:nvSpPr>
         <p:spPr>
           <a:xfrm>
-            <a:off x="10287000" y="396240"/>
-            <a:ext cx="1295400" cy="289560"/>
+            <a:off x="9753600" y="396240"/>
+            <a:ext cx="1828800" cy="289560"/>
           </a:xfrm>
           <a:prstGeom prst="rect">
             <a:avLst/>
@@ -2936,7 +2936,7 @@
                 <a:ea typeface="Instrument Sans" pitchFamily="34" charset="-122"/>
                 <a:cs typeface="Instrument Sans" pitchFamily="34" charset="-120"/>
               </a:rPr>
-              <a:t>AqionLabs</a:t>
+              <a:t>aqionlabs.ai</a:t>
             </a:r>
             <a:endParaRPr lang="en-US" sz="1560" dirty="0"/>
           </a:p>
@@ -5024,8 +5024,8 @@
         </p:nvSpPr>
         <p:spPr>
           <a:xfrm>
-            <a:off x="10287000" y="396240"/>
-            <a:ext cx="1295400" cy="289560"/>
+            <a:off x="9753600" y="396240"/>
+            <a:ext cx="1828800" cy="289560"/>
           </a:xfrm>
           <a:prstGeom prst="rect">
             <a:avLst/>
@@ -5054,7 +5054,7 @@
                 <a:ea typeface="Instrument Sans" pitchFamily="34" charset="-122"/>
                 <a:cs typeface="Instrument Sans" pitchFamily="34" charset="-120"/>
               </a:rPr>
-              <a:t>AqionLabs</a:t>
+              <a:t>aqionlabs.ai</a:t>
             </a:r>
             <a:endParaRPr lang="en-US" sz="1560" dirty="0"/>
           </a:p>
@@ -6110,8 +6110,8 @@
         </p:nvSpPr>
         <p:spPr>
           <a:xfrm>
-            <a:off x="10287000" y="396240"/>
-            <a:ext cx="1295400" cy="289560"/>
+            <a:off x="9753600" y="396240"/>
+            <a:ext cx="1828800" cy="289560"/>
           </a:xfrm>
           <a:prstGeom prst="rect">
             <a:avLst/>
@@ -6140,7 +6140,7 @@
                 <a:ea typeface="Instrument Sans" pitchFamily="34" charset="-122"/>
                 <a:cs typeface="Instrument Sans" pitchFamily="34" charset="-120"/>
               </a:rPr>
-              <a:t>AqionLabs</a:t>
+              <a:t>aqionlabs.ai</a:t>
             </a:r>
             <a:endParaRPr lang="en-US" sz="1560" dirty="0"/>
           </a:p>
@@ -7151,8 +7151,8 @@
         </p:nvSpPr>
         <p:spPr>
           <a:xfrm>
-            <a:off x="10287000" y="396240"/>
-            <a:ext cx="1295400" cy="289560"/>
+            <a:off x="9753600" y="396240"/>
+            <a:ext cx="1828800" cy="289560"/>
           </a:xfrm>
           <a:prstGeom prst="rect">
             <a:avLst/>
@@ -7181,7 +7181,7 @@
                 <a:ea typeface="Instrument Sans" pitchFamily="34" charset="-122"/>
                 <a:cs typeface="Instrument Sans" pitchFamily="34" charset="-120"/>
               </a:rPr>
-              <a:t>AqionLabs</a:t>
+              <a:t>aqionlabs.ai</a:t>
             </a:r>
             <a:endParaRPr lang="en-US" sz="1560" dirty="0"/>
           </a:p>
@@ -8265,8 +8265,8 @@
         </p:nvSpPr>
         <p:spPr>
           <a:xfrm>
-            <a:off x="10287000" y="396240"/>
-            <a:ext cx="1295400" cy="289560"/>
+            <a:off x="9753600" y="396240"/>
+            <a:ext cx="1828800" cy="289560"/>
           </a:xfrm>
           <a:prstGeom prst="rect">
             <a:avLst/>
@@ -8295,7 +8295,7 @@
                 <a:ea typeface="Instrument Sans" pitchFamily="34" charset="-122"/>
                 <a:cs typeface="Instrument Sans" pitchFamily="34" charset="-120"/>
               </a:rPr>
-              <a:t>AqionLabs</a:t>
+              <a:t>aqionlabs.ai</a:t>
             </a:r>
             <a:endParaRPr lang="en-US" sz="1560" dirty="0"/>
           </a:p>
@@ -8508,50 +8508,6 @@
         </p:nvSpPr>
         <p:spPr>
           <a:xfrm>
-            <a:off x="609600" y="5928360"/>
-            <a:ext cx="10972800" cy="320040"/>
-          </a:xfrm>
-          <a:prstGeom prst="rect">
-            <a:avLst/>
-          </a:prstGeom>
-          <a:noFill/>
-          <a:ln/>
-        </p:spPr>
-        <p:txBody>
-          <a:bodyPr wrap="square" lIns="0" tIns="0" rIns="0" bIns="0" rtlCol="0" anchor="t">
-            <a:spAutoFit/>
-          </a:bodyPr>
-          <a:lstStyle/>
-          <a:p>
-            <a:pPr algn="l" indent="0" marL="0">
-              <a:lnSpc>
-                <a:spcPct val="100000"/>
-              </a:lnSpc>
-              <a:buNone/>
-            </a:pPr>
-            <a:r>
-              <a:rPr lang="en-US" sz="1140" dirty="0">
-                <a:solidFill>
-                  <a:srgbClr val="B5D0CD"/>
-                </a:solidFill>
-                <a:latin typeface="Instrument Sans" pitchFamily="34" charset="0"/>
-                <a:ea typeface="Instrument Sans" pitchFamily="34" charset="-122"/>
-                <a:cs typeface="Instrument Sans" pitchFamily="34" charset="-120"/>
-              </a:rPr>
-              <a:t>Aqion Relay / Recover supply. Protect operating cash.</a:t>
-            </a:r>
-            <a:endParaRPr lang="en-US" sz="1140" dirty="0"/>
-          </a:p>
-        </p:txBody>
-      </p:sp>
-      <p:sp>
-        <p:nvSpPr>
-          <p:cNvPr id="11" name="Text 9"/>
-          <p:cNvSpPr/>
-          <p:nvPr/>
-        </p:nvSpPr>
-        <p:spPr>
-          <a:xfrm>
             <a:off x="609600" y="2423160"/>
             <a:ext cx="6248400" cy="1714500"/>
           </a:xfrm>
@@ -8630,7 +8586,7 @@
       </p:sp>
       <p:sp>
         <p:nvSpPr>
-          <p:cNvPr id="12" name="Text 10"/>
+          <p:cNvPr id="11" name="Text 9"/>
           <p:cNvSpPr/>
           <p:nvPr/>
         </p:nvSpPr>
@@ -8674,7 +8630,7 @@
       </p:sp>
       <p:sp>
         <p:nvSpPr>
-          <p:cNvPr id="13" name="Text 11"/>
+          <p:cNvPr id="12" name="Text 10"/>
           <p:cNvSpPr/>
           <p:nvPr/>
         </p:nvSpPr>
@@ -8718,7 +8674,7 @@
       </p:sp>
       <p:sp>
         <p:nvSpPr>
-          <p:cNvPr id="14" name="Text 12"/>
+          <p:cNvPr id="13" name="Text 11"/>
           <p:cNvSpPr/>
           <p:nvPr/>
         </p:nvSpPr>
@@ -8782,7 +8738,7 @@
       </p:sp>
       <p:sp>
         <p:nvSpPr>
-          <p:cNvPr id="15" name="Text 13"/>
+          <p:cNvPr id="14" name="Text 12"/>
           <p:cNvSpPr/>
           <p:nvPr/>
         </p:nvSpPr>
@@ -8826,7 +8782,7 @@
       </p:sp>
       <p:sp>
         <p:nvSpPr>
-          <p:cNvPr id="16" name="Text 14"/>
+          <p:cNvPr id="15" name="Text 13"/>
           <p:cNvSpPr/>
           <p:nvPr/>
         </p:nvSpPr>
@@ -8870,7 +8826,7 @@
       </p:sp>
       <p:sp>
         <p:nvSpPr>
-          <p:cNvPr id="17" name="Text 15"/>
+          <p:cNvPr id="16" name="Text 14"/>
           <p:cNvSpPr/>
           <p:nvPr/>
         </p:nvSpPr>
@@ -8934,7 +8890,7 @@
       </p:sp>
       <p:sp>
         <p:nvSpPr>
-          <p:cNvPr id="18" name="Text 16"/>
+          <p:cNvPr id="17" name="Text 15"/>
           <p:cNvSpPr/>
           <p:nvPr/>
         </p:nvSpPr>
@@ -8978,7 +8934,7 @@
       </p:sp>
       <p:sp>
         <p:nvSpPr>
-          <p:cNvPr id="19" name="Text 17"/>
+          <p:cNvPr id="18" name="Text 16"/>
           <p:cNvSpPr/>
           <p:nvPr/>
         </p:nvSpPr>
@@ -9022,7 +8978,7 @@
       </p:sp>
       <p:sp>
         <p:nvSpPr>
-          <p:cNvPr id="20" name="Text 18"/>
+          <p:cNvPr id="19" name="Text 17"/>
           <p:cNvSpPr/>
           <p:nvPr/>
         </p:nvSpPr>
@@ -9086,7 +9042,7 @@
       </p:sp>
       <p:sp>
         <p:nvSpPr>
-          <p:cNvPr id="21" name="Shape 19"/>
+          <p:cNvPr id="20" name="Shape 18"/>
           <p:cNvSpPr/>
           <p:nvPr/>
         </p:nvSpPr>
@@ -9115,7 +9071,7 @@
       </p:sp>
       <p:sp>
         <p:nvSpPr>
-          <p:cNvPr id="22" name="Text 20"/>
+          <p:cNvPr id="21" name="Text 19"/>
           <p:cNvSpPr/>
           <p:nvPr/>
         </p:nvSpPr>
@@ -9154,6 +9110,200 @@
               <a:t>NEXT MILESTONE / Pilot charter + named owners</a:t>
             </a:r>
             <a:endParaRPr lang="en-US" sz="1080" dirty="0"/>
+          </a:p>
+        </p:txBody>
+      </p:sp>
+      <p:sp>
+        <p:nvSpPr>
+          <p:cNvPr id="22" name="Text 20"/>
+          <p:cNvSpPr/>
+          <p:nvPr/>
+        </p:nvSpPr>
+        <p:spPr>
+          <a:xfrm>
+            <a:off x="609600" y="5722620"/>
+            <a:ext cx="1181100" cy="220980"/>
+          </a:xfrm>
+          <a:prstGeom prst="rect">
+            <a:avLst/>
+          </a:prstGeom>
+          <a:noFill/>
+          <a:ln/>
+        </p:spPr>
+        <p:txBody>
+          <a:bodyPr wrap="square" lIns="0" tIns="0" rIns="0" bIns="0" rtlCol="0" anchor="t">
+            <a:spAutoFit/>
+          </a:bodyPr>
+          <a:lstStyle/>
+          <a:p>
+            <a:pPr algn="l" indent="0" marL="0">
+              <a:lnSpc>
+                <a:spcPct val="100000"/>
+              </a:lnSpc>
+              <a:buNone/>
+            </a:pPr>
+            <a:r>
+              <a:rPr lang="en-US" sz="1080" b="1" dirty="0">
+                <a:solidFill>
+                  <a:srgbClr val="D3EDE0"/>
+                </a:solidFill>
+                <a:latin typeface="Instrument Sans" pitchFamily="34" charset="0"/>
+                <a:ea typeface="Instrument Sans" pitchFamily="34" charset="-122"/>
+                <a:cs typeface="Instrument Sans" pitchFamily="34" charset="-120"/>
+              </a:rPr>
+              <a:t>LIVE MVP</a:t>
+            </a:r>
+            <a:endParaRPr lang="en-US" sz="1080" dirty="0"/>
+          </a:p>
+        </p:txBody>
+      </p:sp>
+      <p:sp>
+        <p:nvSpPr>
+          <p:cNvPr id="23" name="Text 21">
+            <a:hlinkClick r:id="rId1" tooltip=""/>
+          </p:cNvPr>
+          <p:cNvSpPr/>
+          <p:nvPr/>
+        </p:nvSpPr>
+        <p:spPr>
+          <a:xfrm>
+            <a:off x="1905000" y="5722620"/>
+            <a:ext cx="9677400" cy="220980"/>
+          </a:xfrm>
+          <a:prstGeom prst="rect">
+            <a:avLst/>
+          </a:prstGeom>
+          <a:noFill/>
+          <a:ln/>
+        </p:spPr>
+        <p:txBody>
+          <a:bodyPr wrap="square" lIns="0" tIns="0" rIns="0" bIns="0" rtlCol="0" anchor="t">
+            <a:spAutoFit/>
+          </a:bodyPr>
+          <a:lstStyle/>
+          <a:p>
+            <a:pPr algn="l" indent="0" marL="0">
+              <a:lnSpc>
+                <a:spcPct val="100000"/>
+              </a:lnSpc>
+              <a:buNone/>
+            </a:pPr>
+            <a:r>
+              <a:rPr lang="en-US" sz="1200" u="sng" dirty="0">
+                <a:solidFill>
+                  <a:srgbClr val="FFFFFF"/>
+                </a:solidFill>
+                <a:latin typeface="Instrument Sans" pitchFamily="34" charset="0"/>
+                <a:ea typeface="Instrument Sans" pitchFamily="34" charset="-122"/>
+                <a:cs typeface="Instrument Sans" pitchFamily="34" charset="-120"/>
+                <a:hlinkClick r:id="rId1" invalidUrl="" action="" tgtFrame="" tooltip="" history="1" highlightClick="0" endSnd="0">
+                  <a:extLst>
+                    <a:ext uri="{A12FA001-AC4F-418D-AE19-62706E023703}">
+                      <ahyp:hlinkClr xmlns:ahyp="http://schemas.microsoft.com/office/drawing/2018/hyperlinkcolor" val="tx"/>
+                    </a:ext>
+                  </a:extLst>
+                </a:hlinkClick>
+              </a:rPr>
+              <a:t>https://duignytemvp.aqionlabs.workers.dev</a:t>
+            </a:r>
+            <a:endParaRPr lang="en-US" sz="1200" dirty="0"/>
+          </a:p>
+        </p:txBody>
+      </p:sp>
+      <p:sp>
+        <p:nvSpPr>
+          <p:cNvPr id="24" name="Text 22"/>
+          <p:cNvSpPr/>
+          <p:nvPr/>
+        </p:nvSpPr>
+        <p:spPr>
+          <a:xfrm>
+            <a:off x="609600" y="5996940"/>
+            <a:ext cx="1181100" cy="220980"/>
+          </a:xfrm>
+          <a:prstGeom prst="rect">
+            <a:avLst/>
+          </a:prstGeom>
+          <a:noFill/>
+          <a:ln/>
+        </p:spPr>
+        <p:txBody>
+          <a:bodyPr wrap="square" lIns="0" tIns="0" rIns="0" bIns="0" rtlCol="0" anchor="t">
+            <a:spAutoFit/>
+          </a:bodyPr>
+          <a:lstStyle/>
+          <a:p>
+            <a:pPr algn="l" indent="0" marL="0">
+              <a:lnSpc>
+                <a:spcPct val="100000"/>
+              </a:lnSpc>
+              <a:buNone/>
+            </a:pPr>
+            <a:r>
+              <a:rPr lang="en-US" sz="1080" b="1" dirty="0">
+                <a:solidFill>
+                  <a:srgbClr val="D3EDE0"/>
+                </a:solidFill>
+                <a:latin typeface="Instrument Sans" pitchFamily="34" charset="0"/>
+                <a:ea typeface="Instrument Sans" pitchFamily="34" charset="-122"/>
+                <a:cs typeface="Instrument Sans" pitchFamily="34" charset="-120"/>
+              </a:rPr>
+              <a:t>GITHUB</a:t>
+            </a:r>
+            <a:endParaRPr lang="en-US" sz="1080" dirty="0"/>
+          </a:p>
+        </p:txBody>
+      </p:sp>
+      <p:sp>
+        <p:nvSpPr>
+          <p:cNvPr id="25" name="Text 23">
+            <a:hlinkClick r:id="rId2" tooltip=""/>
+          </p:cNvPr>
+          <p:cNvSpPr/>
+          <p:nvPr/>
+        </p:nvSpPr>
+        <p:spPr>
+          <a:xfrm>
+            <a:off x="1905000" y="5996940"/>
+            <a:ext cx="9677400" cy="220980"/>
+          </a:xfrm>
+          <a:prstGeom prst="rect">
+            <a:avLst/>
+          </a:prstGeom>
+          <a:noFill/>
+          <a:ln/>
+        </p:spPr>
+        <p:txBody>
+          <a:bodyPr wrap="square" lIns="0" tIns="0" rIns="0" bIns="0" rtlCol="0" anchor="t">
+            <a:spAutoFit/>
+          </a:bodyPr>
+          <a:lstStyle/>
+          <a:p>
+            <a:pPr algn="l" indent="0" marL="0">
+              <a:lnSpc>
+                <a:spcPct val="100000"/>
+              </a:lnSpc>
+              <a:buNone/>
+            </a:pPr>
+            <a:r>
+              <a:rPr lang="en-US" sz="1200" u="sng" dirty="0">
+                <a:solidFill>
+                  <a:srgbClr val="FFFFFF"/>
+                </a:solidFill>
+                <a:latin typeface="Instrument Sans" pitchFamily="34" charset="0"/>
+                <a:ea typeface="Instrument Sans" pitchFamily="34" charset="-122"/>
+                <a:cs typeface="Instrument Sans" pitchFamily="34" charset="-120"/>
+                <a:hlinkClick r:id="rId2" invalidUrl="" action="" tgtFrame="" tooltip="" history="1" highlightClick="0" endSnd="0">
+                  <a:extLst>
+                    <a:ext uri="{A12FA001-AC4F-418D-AE19-62706E023703}">
+                      <ahyp:hlinkClr xmlns:ahyp="http://schemas.microsoft.com/office/drawing/2018/hyperlinkcolor" val="tx"/>
+                    </a:ext>
+                  </a:extLst>
+                </a:hlinkClick>
+              </a:rPr>
+              <a:t>https://github.com/Jaferdecodesai/DuIgnyteMVP_Aqionlabs</a:t>
+            </a:r>
+            <a:endParaRPr lang="en-US" sz="1200" dirty="0"/>
           </a:p>
         </p:txBody>
       </p:sp>
@@ -9268,8 +9418,8 @@
         </p:nvSpPr>
         <p:spPr>
           <a:xfrm>
-            <a:off x="10287000" y="396240"/>
-            <a:ext cx="1295400" cy="289560"/>
+            <a:off x="9753600" y="396240"/>
+            <a:ext cx="1828800" cy="289560"/>
           </a:xfrm>
           <a:prstGeom prst="rect">
             <a:avLst/>
@@ -9298,7 +9448,7 @@
                 <a:ea typeface="Instrument Sans" pitchFamily="34" charset="-122"/>
                 <a:cs typeface="Instrument Sans" pitchFamily="34" charset="-120"/>
               </a:rPr>
-              <a:t>AqionLabs</a:t>
+              <a:t>aqionlabs.ai</a:t>
             </a:r>
             <a:endParaRPr lang="en-US" sz="1560" dirty="0"/>
           </a:p>
@@ -10080,8 +10230,8 @@
         </p:nvSpPr>
         <p:spPr>
           <a:xfrm>
-            <a:off x="10287000" y="396240"/>
-            <a:ext cx="1295400" cy="289560"/>
+            <a:off x="9753600" y="396240"/>
+            <a:ext cx="1828800" cy="289560"/>
           </a:xfrm>
           <a:prstGeom prst="rect">
             <a:avLst/>
@@ -10110,7 +10260,7 @@
                 <a:ea typeface="Instrument Sans" pitchFamily="34" charset="-122"/>
                 <a:cs typeface="Instrument Sans" pitchFamily="34" charset="-120"/>
               </a:rPr>
-              <a:t>AqionLabs</a:t>
+              <a:t>aqionlabs.ai</a:t>
             </a:r>
             <a:endParaRPr lang="en-US" sz="1560" dirty="0"/>
           </a:p>
@@ -11073,8 +11223,8 @@
         </p:nvSpPr>
         <p:spPr>
           <a:xfrm>
-            <a:off x="10287000" y="396240"/>
-            <a:ext cx="1295400" cy="289560"/>
+            <a:off x="9753600" y="396240"/>
+            <a:ext cx="1828800" cy="289560"/>
           </a:xfrm>
           <a:prstGeom prst="rect">
             <a:avLst/>
@@ -11103,7 +11253,7 @@
                 <a:ea typeface="Instrument Sans" pitchFamily="34" charset="-122"/>
                 <a:cs typeface="Instrument Sans" pitchFamily="34" charset="-120"/>
               </a:rPr>
-              <a:t>AqionLabs</a:t>
+              <a:t>aqionlabs.ai</a:t>
             </a:r>
             <a:endParaRPr lang="en-US" sz="1560" dirty="0"/>
           </a:p>
@@ -12530,8 +12680,8 @@
         </p:nvSpPr>
         <p:spPr>
           <a:xfrm>
-            <a:off x="10287000" y="396240"/>
-            <a:ext cx="1295400" cy="289560"/>
+            <a:off x="9753600" y="396240"/>
+            <a:ext cx="1828800" cy="289560"/>
           </a:xfrm>
           <a:prstGeom prst="rect">
             <a:avLst/>
@@ -12560,7 +12710,7 @@
                 <a:ea typeface="Instrument Sans" pitchFamily="34" charset="-122"/>
                 <a:cs typeface="Instrument Sans" pitchFamily="34" charset="-120"/>
               </a:rPr>
-              <a:t>AqionLabs</a:t>
+              <a:t>aqionlabs.ai</a:t>
             </a:r>
             <a:endParaRPr lang="en-US" sz="1560" dirty="0"/>
           </a:p>
@@ -13587,8 +13737,8 @@
         </p:nvSpPr>
         <p:spPr>
           <a:xfrm>
-            <a:off x="10287000" y="396240"/>
-            <a:ext cx="1295400" cy="289560"/>
+            <a:off x="9753600" y="396240"/>
+            <a:ext cx="1828800" cy="289560"/>
           </a:xfrm>
           <a:prstGeom prst="rect">
             <a:avLst/>
@@ -13617,7 +13767,7 @@
                 <a:ea typeface="Instrument Sans" pitchFamily="34" charset="-122"/>
                 <a:cs typeface="Instrument Sans" pitchFamily="34" charset="-120"/>
               </a:rPr>
-              <a:t>AqionLabs</a:t>
+              <a:t>aqionlabs.ai</a:t>
             </a:r>
             <a:endParaRPr lang="en-US" sz="1560" dirty="0"/>
           </a:p>
@@ -14680,8 +14830,8 @@
         </p:nvSpPr>
         <p:spPr>
           <a:xfrm>
-            <a:off x="10287000" y="396240"/>
-            <a:ext cx="1295400" cy="289560"/>
+            <a:off x="9753600" y="396240"/>
+            <a:ext cx="1828800" cy="289560"/>
           </a:xfrm>
           <a:prstGeom prst="rect">
             <a:avLst/>
@@ -14710,7 +14860,7 @@
                 <a:ea typeface="Instrument Sans" pitchFamily="34" charset="-122"/>
                 <a:cs typeface="Instrument Sans" pitchFamily="34" charset="-120"/>
               </a:rPr>
-              <a:t>AqionLabs</a:t>
+              <a:t>aqionlabs.ai</a:t>
             </a:r>
             <a:endParaRPr lang="en-US" sz="1560" dirty="0"/>
           </a:p>
@@ -14966,7 +15116,9 @@
       </p:sp>
       <p:pic>
         <p:nvPicPr>
-          <p:cNvPr id="11" name="Image 0" descr="/Users/user/Documents/ChatGPT/Ignite Challenges/du-relay-web/pitch/assets/live-mvp.png">    </p:cNvPr>
+          <p:cNvPr id="11" name="Image 0" descr="/Users/user/Documents/ChatGPT/Ignite Challenges/du-relay-web/pitch/assets/live-mvp.png">
+            <a:hlinkClick r:id="rId2" tooltip=""/>
+          </p:cNvPr>
           <p:cNvPicPr>
             <a:picLocks noChangeAspect="1"/>
           </p:cNvPicPr>
@@ -14990,45 +15142,54 @@
       </p:pic>
       <p:sp>
         <p:nvSpPr>
-          <p:cNvPr id="12" name="Text 9"/>
-          <p:cNvSpPr/>
-          <p:nvPr/>
-        </p:nvSpPr>
-        <p:spPr>
-          <a:xfrm>
-            <a:off x="800100" y="5699760"/>
-            <a:ext cx="4572000" cy="228600"/>
-          </a:xfrm>
-          <a:prstGeom prst="rect">
-            <a:avLst/>
-          </a:prstGeom>
-          <a:noFill/>
-          <a:ln/>
-        </p:spPr>
-        <p:txBody>
-          <a:bodyPr wrap="square" lIns="0" tIns="0" rIns="0" bIns="0" rtlCol="0" anchor="t">
-            <a:spAutoFit/>
-          </a:bodyPr>
-          <a:lstStyle/>
-          <a:p>
-            <a:pPr algn="l" indent="0" marL="0">
-              <a:lnSpc>
-                <a:spcPct val="100000"/>
-              </a:lnSpc>
-              <a:buNone/>
-            </a:pPr>
-            <a:r>
-              <a:rPr lang="en-US" sz="1080" dirty="0">
-                <a:solidFill>
-                  <a:srgbClr val="536D74"/>
-                </a:solidFill>
-                <a:latin typeface="Instrument Sans" pitchFamily="34" charset="0"/>
-                <a:ea typeface="Instrument Sans" pitchFamily="34" charset="-122"/>
-                <a:cs typeface="Instrument Sans" pitchFamily="34" charset="-120"/>
-              </a:rPr>
-              <a:t>Live Cloudflare MVP · synthetic scenario</a:t>
-            </a:r>
-            <a:endParaRPr lang="en-US" sz="1080" dirty="0"/>
+          <p:cNvPr id="12" name="Text 9">
+            <a:hlinkClick r:id="rId3" tooltip=""/>
+          </p:cNvPr>
+          <p:cNvSpPr/>
+          <p:nvPr/>
+        </p:nvSpPr>
+        <p:spPr>
+          <a:xfrm>
+            <a:off x="800100" y="5379720"/>
+            <a:ext cx="3733800" cy="198120"/>
+          </a:xfrm>
+          <a:prstGeom prst="rect">
+            <a:avLst/>
+          </a:prstGeom>
+          <a:noFill/>
+          <a:ln/>
+        </p:spPr>
+        <p:txBody>
+          <a:bodyPr wrap="square" lIns="0" tIns="0" rIns="0" bIns="0" rtlCol="0" anchor="t">
+            <a:spAutoFit/>
+          </a:bodyPr>
+          <a:lstStyle/>
+          <a:p>
+            <a:pPr algn="l" indent="0" marL="0">
+              <a:lnSpc>
+                <a:spcPct val="100000"/>
+              </a:lnSpc>
+              <a:buNone/>
+            </a:pPr>
+            <a:r>
+              <a:rPr lang="en-US" sz="1020" u="sng" dirty="0">
+                <a:solidFill>
+                  <a:srgbClr val="D3EDE0"/>
+                </a:solidFill>
+                <a:latin typeface="Instrument Sans" pitchFamily="34" charset="0"/>
+                <a:ea typeface="Instrument Sans" pitchFamily="34" charset="-122"/>
+                <a:cs typeface="Instrument Sans" pitchFamily="34" charset="-120"/>
+                <a:hlinkClick r:id="rId3" invalidUrl="" action="" tgtFrame="" tooltip="" history="1" highlightClick="0" endSnd="0">
+                  <a:extLst>
+                    <a:ext uri="{A12FA001-AC4F-418D-AE19-62706E023703}">
+                      <ahyp:hlinkClr xmlns:ahyp="http://schemas.microsoft.com/office/drawing/2018/hyperlinkcolor" val="tx"/>
+                    </a:ext>
+                  </a:extLst>
+                </a:hlinkClick>
+              </a:rPr>
+              <a:t>Open the live MVP · synthetic scenario</a:t>
+            </a:r>
+            <a:endParaRPr lang="en-US" sz="1020" dirty="0"/>
           </a:p>
         </p:txBody>
       </p:sp>
@@ -15425,6 +15586,200 @@
               <a:t>Persisted drafts, readable audit history and portable JSON.</a:t>
             </a:r>
             <a:endParaRPr lang="en-US" sz="1500" dirty="0"/>
+          </a:p>
+        </p:txBody>
+      </p:sp>
+      <p:sp>
+        <p:nvSpPr>
+          <p:cNvPr id="22" name="Text 19"/>
+          <p:cNvSpPr/>
+          <p:nvPr/>
+        </p:nvSpPr>
+        <p:spPr>
+          <a:xfrm>
+            <a:off x="609600" y="5722620"/>
+            <a:ext cx="1181100" cy="220980"/>
+          </a:xfrm>
+          <a:prstGeom prst="rect">
+            <a:avLst/>
+          </a:prstGeom>
+          <a:noFill/>
+          <a:ln/>
+        </p:spPr>
+        <p:txBody>
+          <a:bodyPr wrap="square" lIns="0" tIns="0" rIns="0" bIns="0" rtlCol="0" anchor="t">
+            <a:spAutoFit/>
+          </a:bodyPr>
+          <a:lstStyle/>
+          <a:p>
+            <a:pPr algn="l" indent="0" marL="0">
+              <a:lnSpc>
+                <a:spcPct val="100000"/>
+              </a:lnSpc>
+              <a:buNone/>
+            </a:pPr>
+            <a:r>
+              <a:rPr lang="en-US" sz="1080" b="1" dirty="0">
+                <a:solidFill>
+                  <a:srgbClr val="087F80"/>
+                </a:solidFill>
+                <a:latin typeface="Instrument Sans" pitchFamily="34" charset="0"/>
+                <a:ea typeface="Instrument Sans" pitchFamily="34" charset="-122"/>
+                <a:cs typeface="Instrument Sans" pitchFamily="34" charset="-120"/>
+              </a:rPr>
+              <a:t>LIVE MVP</a:t>
+            </a:r>
+            <a:endParaRPr lang="en-US" sz="1080" dirty="0"/>
+          </a:p>
+        </p:txBody>
+      </p:sp>
+      <p:sp>
+        <p:nvSpPr>
+          <p:cNvPr id="23" name="Text 20">
+            <a:hlinkClick r:id="rId4" tooltip=""/>
+          </p:cNvPr>
+          <p:cNvSpPr/>
+          <p:nvPr/>
+        </p:nvSpPr>
+        <p:spPr>
+          <a:xfrm>
+            <a:off x="1905000" y="5722620"/>
+            <a:ext cx="9677400" cy="220980"/>
+          </a:xfrm>
+          <a:prstGeom prst="rect">
+            <a:avLst/>
+          </a:prstGeom>
+          <a:noFill/>
+          <a:ln/>
+        </p:spPr>
+        <p:txBody>
+          <a:bodyPr wrap="square" lIns="0" tIns="0" rIns="0" bIns="0" rtlCol="0" anchor="t">
+            <a:spAutoFit/>
+          </a:bodyPr>
+          <a:lstStyle/>
+          <a:p>
+            <a:pPr algn="l" indent="0" marL="0">
+              <a:lnSpc>
+                <a:spcPct val="100000"/>
+              </a:lnSpc>
+              <a:buNone/>
+            </a:pPr>
+            <a:r>
+              <a:rPr lang="en-US" sz="1200" u="sng" dirty="0">
+                <a:solidFill>
+                  <a:srgbClr val="102F3A"/>
+                </a:solidFill>
+                <a:latin typeface="Instrument Sans" pitchFamily="34" charset="0"/>
+                <a:ea typeface="Instrument Sans" pitchFamily="34" charset="-122"/>
+                <a:cs typeface="Instrument Sans" pitchFamily="34" charset="-120"/>
+                <a:hlinkClick r:id="rId4" invalidUrl="" action="" tgtFrame="" tooltip="" history="1" highlightClick="0" endSnd="0">
+                  <a:extLst>
+                    <a:ext uri="{A12FA001-AC4F-418D-AE19-62706E023703}">
+                      <ahyp:hlinkClr xmlns:ahyp="http://schemas.microsoft.com/office/drawing/2018/hyperlinkcolor" val="tx"/>
+                    </a:ext>
+                  </a:extLst>
+                </a:hlinkClick>
+              </a:rPr>
+              <a:t>https://duignytemvp.aqionlabs.workers.dev</a:t>
+            </a:r>
+            <a:endParaRPr lang="en-US" sz="1200" dirty="0"/>
+          </a:p>
+        </p:txBody>
+      </p:sp>
+      <p:sp>
+        <p:nvSpPr>
+          <p:cNvPr id="24" name="Text 21"/>
+          <p:cNvSpPr/>
+          <p:nvPr/>
+        </p:nvSpPr>
+        <p:spPr>
+          <a:xfrm>
+            <a:off x="609600" y="5996940"/>
+            <a:ext cx="1181100" cy="220980"/>
+          </a:xfrm>
+          <a:prstGeom prst="rect">
+            <a:avLst/>
+          </a:prstGeom>
+          <a:noFill/>
+          <a:ln/>
+        </p:spPr>
+        <p:txBody>
+          <a:bodyPr wrap="square" lIns="0" tIns="0" rIns="0" bIns="0" rtlCol="0" anchor="t">
+            <a:spAutoFit/>
+          </a:bodyPr>
+          <a:lstStyle/>
+          <a:p>
+            <a:pPr algn="l" indent="0" marL="0">
+              <a:lnSpc>
+                <a:spcPct val="100000"/>
+              </a:lnSpc>
+              <a:buNone/>
+            </a:pPr>
+            <a:r>
+              <a:rPr lang="en-US" sz="1080" b="1" dirty="0">
+                <a:solidFill>
+                  <a:srgbClr val="087F80"/>
+                </a:solidFill>
+                <a:latin typeface="Instrument Sans" pitchFamily="34" charset="0"/>
+                <a:ea typeface="Instrument Sans" pitchFamily="34" charset="-122"/>
+                <a:cs typeface="Instrument Sans" pitchFamily="34" charset="-120"/>
+              </a:rPr>
+              <a:t>GITHUB</a:t>
+            </a:r>
+            <a:endParaRPr lang="en-US" sz="1080" dirty="0"/>
+          </a:p>
+        </p:txBody>
+      </p:sp>
+      <p:sp>
+        <p:nvSpPr>
+          <p:cNvPr id="25" name="Text 22">
+            <a:hlinkClick r:id="rId5" tooltip=""/>
+          </p:cNvPr>
+          <p:cNvSpPr/>
+          <p:nvPr/>
+        </p:nvSpPr>
+        <p:spPr>
+          <a:xfrm>
+            <a:off x="1905000" y="5996940"/>
+            <a:ext cx="9677400" cy="220980"/>
+          </a:xfrm>
+          <a:prstGeom prst="rect">
+            <a:avLst/>
+          </a:prstGeom>
+          <a:noFill/>
+          <a:ln/>
+        </p:spPr>
+        <p:txBody>
+          <a:bodyPr wrap="square" lIns="0" tIns="0" rIns="0" bIns="0" rtlCol="0" anchor="t">
+            <a:spAutoFit/>
+          </a:bodyPr>
+          <a:lstStyle/>
+          <a:p>
+            <a:pPr algn="l" indent="0" marL="0">
+              <a:lnSpc>
+                <a:spcPct val="100000"/>
+              </a:lnSpc>
+              <a:buNone/>
+            </a:pPr>
+            <a:r>
+              <a:rPr lang="en-US" sz="1200" u="sng" dirty="0">
+                <a:solidFill>
+                  <a:srgbClr val="102F3A"/>
+                </a:solidFill>
+                <a:latin typeface="Instrument Sans" pitchFamily="34" charset="0"/>
+                <a:ea typeface="Instrument Sans" pitchFamily="34" charset="-122"/>
+                <a:cs typeface="Instrument Sans" pitchFamily="34" charset="-120"/>
+                <a:hlinkClick r:id="rId5" invalidUrl="" action="" tgtFrame="" tooltip="" history="1" highlightClick="0" endSnd="0">
+                  <a:extLst>
+                    <a:ext uri="{A12FA001-AC4F-418D-AE19-62706E023703}">
+                      <ahyp:hlinkClr xmlns:ahyp="http://schemas.microsoft.com/office/drawing/2018/hyperlinkcolor" val="tx"/>
+                    </a:ext>
+                  </a:extLst>
+                </a:hlinkClick>
+              </a:rPr>
+              <a:t>https://github.com/Jaferdecodesai/DuIgnyteMVP_Aqionlabs</a:t>
+            </a:r>
+            <a:endParaRPr lang="en-US" sz="1200" dirty="0"/>
           </a:p>
         </p:txBody>
       </p:sp>
@@ -15539,8 +15894,8 @@
         </p:nvSpPr>
         <p:spPr>
           <a:xfrm>
-            <a:off x="10287000" y="396240"/>
-            <a:ext cx="1295400" cy="289560"/>
+            <a:off x="9753600" y="396240"/>
+            <a:ext cx="1828800" cy="289560"/>
           </a:xfrm>
           <a:prstGeom prst="rect">
             <a:avLst/>
@@ -15569,7 +15924,7 @@
                 <a:ea typeface="Instrument Sans" pitchFamily="34" charset="-122"/>
                 <a:cs typeface="Instrument Sans" pitchFamily="34" charset="-120"/>
               </a:rPr>
-              <a:t>AqionLabs</a:t>
+              <a:t>aqionlabs.ai</a:t>
             </a:r>
             <a:endParaRPr lang="en-US" sz="1560" dirty="0"/>
           </a:p>
@@ -16714,6 +17069,103 @@
                 <a:cs typeface="Instrument Sans" pitchFamily="34" charset="-120"/>
               </a:rPr>
               <a:t>Human confirmation</a:t>
+            </a:r>
+            <a:endParaRPr lang="en-US" sz="1080" dirty="0"/>
+          </a:p>
+        </p:txBody>
+      </p:sp>
+      <p:sp>
+        <p:nvSpPr>
+          <p:cNvPr id="33" name="Text 31"/>
+          <p:cNvSpPr/>
+          <p:nvPr/>
+        </p:nvSpPr>
+        <p:spPr>
+          <a:xfrm>
+            <a:off x="609600" y="5638800"/>
+            <a:ext cx="1562100" cy="228600"/>
+          </a:xfrm>
+          <a:prstGeom prst="rect">
+            <a:avLst/>
+          </a:prstGeom>
+          <a:noFill/>
+          <a:ln/>
+        </p:spPr>
+        <p:txBody>
+          <a:bodyPr wrap="square" lIns="0" tIns="0" rIns="0" bIns="0" rtlCol="0" anchor="t">
+            <a:spAutoFit/>
+          </a:bodyPr>
+          <a:lstStyle/>
+          <a:p>
+            <a:pPr algn="l" indent="0" marL="0">
+              <a:lnSpc>
+                <a:spcPct val="100000"/>
+              </a:lnSpc>
+              <a:buNone/>
+            </a:pPr>
+            <a:r>
+              <a:rPr lang="en-US" sz="1080" b="1" dirty="0">
+                <a:solidFill>
+                  <a:srgbClr val="087F80"/>
+                </a:solidFill>
+                <a:latin typeface="Instrument Sans" pitchFamily="34" charset="0"/>
+                <a:ea typeface="Instrument Sans" pitchFamily="34" charset="-122"/>
+                <a:cs typeface="Instrument Sans" pitchFamily="34" charset="-120"/>
+              </a:rPr>
+              <a:t>SYSTEM DESIGN</a:t>
+            </a:r>
+            <a:endParaRPr lang="en-US" sz="1080" dirty="0"/>
+          </a:p>
+        </p:txBody>
+      </p:sp>
+      <p:sp>
+        <p:nvSpPr>
+          <p:cNvPr id="34" name="Text 32">
+            <a:hlinkClick r:id="rId1" tooltip=""/>
+          </p:cNvPr>
+          <p:cNvSpPr/>
+          <p:nvPr/>
+        </p:nvSpPr>
+        <p:spPr>
+          <a:xfrm>
+            <a:off x="2286000" y="5638800"/>
+            <a:ext cx="9296400" cy="228600"/>
+          </a:xfrm>
+          <a:prstGeom prst="rect">
+            <a:avLst/>
+          </a:prstGeom>
+          <a:noFill/>
+          <a:ln/>
+        </p:spPr>
+        <p:txBody>
+          <a:bodyPr wrap="square" lIns="0" tIns="0" rIns="0" bIns="0" rtlCol="0" anchor="t">
+            <a:spAutoFit/>
+          </a:bodyPr>
+          <a:lstStyle/>
+          <a:p>
+            <a:pPr algn="l" indent="0" marL="0">
+              <a:lnSpc>
+                <a:spcPct val="100000"/>
+              </a:lnSpc>
+              <a:buNone/>
+            </a:pPr>
+            <a:r>
+              <a:rPr lang="en-US" sz="1080" u="sng" dirty="0">
+                <a:solidFill>
+                  <a:srgbClr val="102F3A"/>
+                </a:solidFill>
+                <a:latin typeface="Instrument Sans" pitchFamily="34" charset="0"/>
+                <a:ea typeface="Instrument Sans" pitchFamily="34" charset="-122"/>
+                <a:cs typeface="Instrument Sans" pitchFamily="34" charset="-120"/>
+                <a:hlinkClick r:id="rId1" invalidUrl="" action="" tgtFrame="" tooltip="" history="1" highlightClick="0" endSnd="0">
+                  <a:extLst>
+                    <a:ext uri="{A12FA001-AC4F-418D-AE19-62706E023703}">
+                      <ahyp:hlinkClr xmlns:ahyp="http://schemas.microsoft.com/office/drawing/2018/hyperlinkcolor" val="tx"/>
+                    </a:ext>
+                  </a:extLst>
+                </a:hlinkClick>
+              </a:rPr>
+              <a:t>https://github.com/Jaferdecodesai/DuIgnyteMVP_Aqionlabs/blob/main/Aqion-Relay-System-Design.docx</a:t>
             </a:r>
             <a:endParaRPr lang="en-US" sz="1080" dirty="0"/>
           </a:p>
@@ -16830,8 +17282,8 @@
         </p:nvSpPr>
         <p:spPr>
           <a:xfrm>
-            <a:off x="10287000" y="396240"/>
-            <a:ext cx="1295400" cy="289560"/>
+            <a:off x="9753600" y="396240"/>
+            <a:ext cx="1828800" cy="289560"/>
           </a:xfrm>
           <a:prstGeom prst="rect">
             <a:avLst/>
@@ -16860,7 +17312,7 @@
                 <a:ea typeface="Instrument Sans" pitchFamily="34" charset="-122"/>
                 <a:cs typeface="Instrument Sans" pitchFamily="34" charset="-120"/>
               </a:rPr>
-              <a:t>AqionLabs</a:t>
+              <a:t>aqionlabs.ai</a:t>
             </a:r>
             <a:endParaRPr lang="en-US" sz="1560" dirty="0"/>
           </a:p>

</xml_diff>